<commit_message>
small updates to day 3 wording
</commit_message>
<xml_diff>
--- a/lessons/Day3/C_regression.pptx
+++ b/lessons/Day3/C_regression.pptx
@@ -6222,7 +6222,7 @@
           <a:p>
             <a:fld id="{B0C0A60C-850A-4EA4-9C14-A8FE98B94505}" type="datetimeFigureOut">
               <a:rPr lang="en-US" smtClean="0"/>
-              <a:t>6/7/26</a:t>
+              <a:t>6/10/26</a:t>
             </a:fld>
             <a:endParaRPr lang="en-US"/>
           </a:p>
@@ -8120,7 +8120,7 @@
           <a:p>
             <a:fld id="{5738B90E-0779-4C36-915C-6F05FCD89456}" type="datetime1">
               <a:rPr lang="en-US" smtClean="0"/>
-              <a:t>6/7/26</a:t>
+              <a:t>6/10/26</a:t>
             </a:fld>
             <a:endParaRPr lang="en-US"/>
           </a:p>
@@ -8317,7 +8317,7 @@
           <a:p>
             <a:fld id="{7B9EA29D-D431-42FE-B7B6-AAE4454C77D3}" type="datetime1">
               <a:rPr lang="en-US" smtClean="0"/>
-              <a:t>6/7/26</a:t>
+              <a:t>6/10/26</a:t>
             </a:fld>
             <a:endParaRPr lang="en-US"/>
           </a:p>
@@ -8672,7 +8672,7 @@
           <a:p>
             <a:fld id="{690D8A1E-EA8F-46C1-B891-AE0C00D9C314}" type="datetime1">
               <a:rPr lang="en-US" smtClean="0"/>
-              <a:t>6/7/26</a:t>
+              <a:t>6/10/26</a:t>
             </a:fld>
             <a:endParaRPr lang="en-US"/>
           </a:p>
@@ -8980,7 +8980,7 @@
           <a:p>
             <a:fld id="{D753EFC8-4232-4598-94F6-94C0EBAFC469}" type="datetime1">
               <a:rPr lang="en-US" smtClean="0"/>
-              <a:t>6/7/26</a:t>
+              <a:t>6/10/26</a:t>
             </a:fld>
             <a:endParaRPr lang="en-US"/>
           </a:p>
@@ -9309,7 +9309,7 @@
           <a:p>
             <a:fld id="{F3161074-1C18-4AE7-957D-F18524378C85}" type="datetime1">
               <a:rPr lang="en-US" smtClean="0"/>
-              <a:t>6/7/26</a:t>
+              <a:t>6/10/26</a:t>
             </a:fld>
             <a:endParaRPr lang="en-US"/>
           </a:p>
@@ -9562,7 +9562,7 @@
           <a:p>
             <a:fld id="{69BE256C-8D9A-4404-B47D-41A1AE514425}" type="datetime1">
               <a:rPr lang="en-US" smtClean="0"/>
-              <a:t>6/7/26</a:t>
+              <a:t>6/10/26</a:t>
             </a:fld>
             <a:endParaRPr lang="en-US"/>
           </a:p>
@@ -10010,7 +10010,7 @@
           <a:p>
             <a:fld id="{66CB2154-9035-4012-8189-BAAB61C5A5EE}" type="datetime1">
               <a:rPr lang="en-US" smtClean="0"/>
-              <a:t>6/7/26</a:t>
+              <a:t>6/10/26</a:t>
             </a:fld>
             <a:endParaRPr lang="en-US"/>
           </a:p>
@@ -10198,7 +10198,7 @@
           <a:p>
             <a:fld id="{6700A58B-DD98-43D0-B791-721480A02982}" type="datetime1">
               <a:rPr lang="en-US" smtClean="0"/>
-              <a:t>6/7/26</a:t>
+              <a:t>6/10/26</a:t>
             </a:fld>
             <a:endParaRPr lang="en-US"/>
           </a:p>
@@ -10404,7 +10404,7 @@
           <a:p>
             <a:fld id="{7DB6E382-4F61-4E24-BE1A-377EC83D0E3A}" type="datetime1">
               <a:rPr lang="en-US" smtClean="0"/>
-              <a:t>6/7/26</a:t>
+              <a:t>6/10/26</a:t>
             </a:fld>
             <a:endParaRPr lang="en-US"/>
           </a:p>
@@ -10810,7 +10810,7 @@
           <a:p>
             <a:fld id="{4142EED6-FC16-45B9-B8C4-2BC5DBA88325}" type="datetime1">
               <a:rPr lang="en-US" smtClean="0"/>
-              <a:t>6/7/26</a:t>
+              <a:t>6/10/26</a:t>
             </a:fld>
             <a:endParaRPr lang="en-US"/>
           </a:p>
@@ -11142,7 +11142,7 @@
           <a:p>
             <a:fld id="{DF59512B-4F1D-43D7-8819-2F53FEF69650}" type="datetime1">
               <a:rPr lang="en-US" smtClean="0"/>
-              <a:t>6/7/26</a:t>
+              <a:t>6/10/26</a:t>
             </a:fld>
             <a:endParaRPr lang="en-US"/>
           </a:p>
@@ -11432,7 +11432,7 @@
           <a:p>
             <a:fld id="{08437B94-E2BF-44DC-ADC5-B05FC9934E9D}" type="datetime1">
               <a:rPr lang="en-US" smtClean="0"/>
-              <a:t>6/7/26</a:t>
+              <a:t>6/10/26</a:t>
             </a:fld>
             <a:endParaRPr lang="en-US"/>
           </a:p>
@@ -11871,7 +11871,7 @@
           <a:p>
             <a:fld id="{6700A58B-DD98-43D0-B791-721480A02982}" type="datetime1">
               <a:rPr lang="en-US" smtClean="0"/>
-              <a:t>6/7/26</a:t>
+              <a:t>6/10/26</a:t>
             </a:fld>
             <a:endParaRPr lang="en-US"/>
           </a:p>
@@ -13805,7 +13805,7 @@
             <a:fld id="{9B19E99B-5349-415A-8E56-8E989211A366}" type="datetime1">
               <a:rPr lang="en-US" smtClean="0"/>
               <a:pPr/>
-              <a:t>6/7/26</a:t>
+              <a:t>6/10/26</a:t>
             </a:fld>
             <a:endParaRPr lang="en-US"/>
           </a:p>
@@ -14356,7 +14356,7 @@
           <a:p>
             <a:fld id="{6700A58B-DD98-43D0-B791-721480A02982}" type="datetime1">
               <a:rPr lang="en-US" smtClean="0"/>
-              <a:t>6/7/26</a:t>
+              <a:t>6/10/26</a:t>
             </a:fld>
             <a:endParaRPr lang="en-US"/>
           </a:p>
@@ -15071,7 +15071,7 @@
           <a:p>
             <a:fld id="{6700A58B-DD98-43D0-B791-721480A02982}" type="datetime1">
               <a:rPr lang="en-US" smtClean="0"/>
-              <a:t>6/7/26</a:t>
+              <a:t>6/10/26</a:t>
             </a:fld>
             <a:endParaRPr lang="en-US"/>
           </a:p>
@@ -15857,7 +15857,7 @@
             <a:fld id="{6700A58B-DD98-43D0-B791-721480A02982}" type="datetime1">
               <a:rPr lang="en-US" smtClean="0"/>
               <a:pPr/>
-              <a:t>6/7/26</a:t>
+              <a:t>6/10/26</a:t>
             </a:fld>
             <a:endParaRPr lang="en-US"/>
           </a:p>
@@ -16216,7 +16216,7 @@
             <a:fld id="{9B19E99B-5349-415A-8E56-8E989211A366}" type="datetime1">
               <a:rPr lang="en-US" smtClean="0"/>
               <a:pPr/>
-              <a:t>6/7/26</a:t>
+              <a:t>6/10/26</a:t>
             </a:fld>
             <a:endParaRPr lang="en-US"/>
           </a:p>
@@ -16471,7 +16471,7 @@
             <a:fld id="{6700A58B-DD98-43D0-B791-721480A02982}" type="datetime1">
               <a:rPr lang="en-US" smtClean="0"/>
               <a:pPr/>
-              <a:t>6/7/26</a:t>
+              <a:t>6/10/26</a:t>
             </a:fld>
             <a:endParaRPr lang="en-US"/>
           </a:p>
@@ -17142,7 +17142,7 @@
             <a:fld id="{6700A58B-DD98-43D0-B791-721480A02982}" type="datetime1">
               <a:rPr lang="en-US" smtClean="0"/>
               <a:pPr/>
-              <a:t>6/7/26</a:t>
+              <a:t>6/10/26</a:t>
             </a:fld>
             <a:endParaRPr lang="en-US"/>
           </a:p>
@@ -17900,7 +17900,7 @@
             <a:fld id="{6700A58B-DD98-43D0-B791-721480A02982}" type="datetime1">
               <a:rPr lang="en-US" smtClean="0"/>
               <a:pPr/>
-              <a:t>6/7/26</a:t>
+              <a:t>6/10/26</a:t>
             </a:fld>
             <a:endParaRPr lang="en-US"/>
           </a:p>
@@ -18230,7 +18230,7 @@
             <a:fld id="{6700A58B-DD98-43D0-B791-721480A02982}" type="datetime1">
               <a:rPr lang="en-US" smtClean="0"/>
               <a:pPr/>
-              <a:t>6/7/26</a:t>
+              <a:t>6/10/26</a:t>
             </a:fld>
             <a:endParaRPr lang="en-US"/>
           </a:p>
@@ -18589,7 +18589,7 @@
             <a:fld id="{6700A58B-DD98-43D0-B791-721480A02982}" type="datetime1">
               <a:rPr lang="en-US" smtClean="0"/>
               <a:pPr/>
-              <a:t>6/7/26</a:t>
+              <a:t>6/10/26</a:t>
             </a:fld>
             <a:endParaRPr lang="en-US"/>
           </a:p>
@@ -19010,7 +19010,7 @@
             <a:fld id="{D753EFC8-4232-4598-94F6-94C0EBAFC469}" type="datetime1">
               <a:rPr lang="en-US" smtClean="0"/>
               <a:pPr/>
-              <a:t>6/7/26</a:t>
+              <a:t>6/10/26</a:t>
             </a:fld>
             <a:endParaRPr lang="en-US"/>
           </a:p>
@@ -20574,7 +20574,7 @@
             <a:fld id="{6700A58B-DD98-43D0-B791-721480A02982}" type="datetime1">
               <a:rPr lang="en-US" smtClean="0"/>
               <a:pPr/>
-              <a:t>6/7/26</a:t>
+              <a:t>6/10/26</a:t>
             </a:fld>
             <a:endParaRPr lang="en-US"/>
           </a:p>
@@ -20945,7 +20945,7 @@
           <a:p>
             <a:fld id="{6700A58B-DD98-43D0-B791-721480A02982}" type="datetime1">
               <a:rPr lang="en-US" smtClean="0"/>
-              <a:t>6/7/26</a:t>
+              <a:t>6/10/26</a:t>
             </a:fld>
             <a:endParaRPr lang="en-US"/>
           </a:p>
@@ -21255,7 +21255,7 @@
             <a:fld id="{9B19E99B-5349-415A-8E56-8E989211A366}" type="datetime1">
               <a:rPr lang="en-US" smtClean="0"/>
               <a:pPr/>
-              <a:t>6/7/26</a:t>
+              <a:t>6/10/26</a:t>
             </a:fld>
             <a:endParaRPr lang="en-US"/>
           </a:p>
@@ -22293,7 +22293,7 @@
             <a:fld id="{9B19E99B-5349-415A-8E56-8E989211A366}" type="datetime1">
               <a:rPr lang="en-US" smtClean="0"/>
               <a:pPr/>
-              <a:t>6/7/26</a:t>
+              <a:t>6/10/26</a:t>
             </a:fld>
             <a:endParaRPr lang="en-US"/>
           </a:p>
@@ -22624,11 +22624,7 @@
             <a:pPr lvl="1"/>
             <a:r>
               <a:rPr lang="en-US" dirty="0"/>
-              <a:t>MLE calculates the probability of observing Y given various values for every possible beta </a:t>
-            </a:r>
-            <a:r>
-              <a:rPr lang="en-US" dirty="0" err="1"/>
-              <a:t>coeeficient</a:t>
+              <a:t>MLE calculates the probability of observing Y given various values for every possible beta coefficient</a:t>
             </a:r>
             <a:endParaRPr lang="en-US" i="1" dirty="0"/>
           </a:p>
@@ -22816,7 +22812,7 @@
             <a:fld id="{9B19E99B-5349-415A-8E56-8E989211A366}" type="datetime1">
               <a:rPr lang="en-US" smtClean="0"/>
               <a:pPr/>
-              <a:t>6/7/26</a:t>
+              <a:t>6/10/26</a:t>
             </a:fld>
             <a:endParaRPr lang="en-US"/>
           </a:p>
@@ -23126,7 +23122,7 @@
             <a:fld id="{9B19E99B-5349-415A-8E56-8E989211A366}" type="datetime1">
               <a:rPr lang="en-US" smtClean="0"/>
               <a:pPr/>
-              <a:t>6/7/26</a:t>
+              <a:t>6/10/26</a:t>
             </a:fld>
             <a:endParaRPr lang="en-US"/>
           </a:p>
@@ -23565,7 +23561,7 @@
             <a:fld id="{9B19E99B-5349-415A-8E56-8E989211A366}" type="datetime1">
               <a:rPr lang="en-US" smtClean="0"/>
               <a:pPr/>
-              <a:t>6/7/26</a:t>
+              <a:t>6/10/26</a:t>
             </a:fld>
             <a:endParaRPr lang="en-US"/>
           </a:p>
@@ -24014,7 +24010,7 @@
           <a:p>
             <a:fld id="{6700A58B-DD98-43D0-B791-721480A02982}" type="datetime1">
               <a:rPr lang="en-US" smtClean="0"/>
-              <a:t>6/7/26</a:t>
+              <a:t>6/10/26</a:t>
             </a:fld>
             <a:endParaRPr lang="en-US"/>
           </a:p>
@@ -24329,7 +24325,7 @@
           <a:p>
             <a:fld id="{6700A58B-DD98-43D0-B791-721480A02982}" type="datetime1">
               <a:rPr lang="en-US" smtClean="0"/>
-              <a:t>6/7/26</a:t>
+              <a:t>6/10/26</a:t>
             </a:fld>
             <a:endParaRPr lang="en-US"/>
           </a:p>
@@ -25270,7 +25266,7 @@
           <a:p>
             <a:fld id="{6700A58B-DD98-43D0-B791-721480A02982}" type="datetime1">
               <a:rPr lang="en-US" smtClean="0"/>
-              <a:t>6/7/26</a:t>
+              <a:t>6/10/26</a:t>
             </a:fld>
             <a:endParaRPr lang="en-US"/>
           </a:p>
@@ -25625,7 +25621,7 @@
             <a:fld id="{9B19E99B-5349-415A-8E56-8E989211A366}" type="datetime1">
               <a:rPr lang="en-US" smtClean="0"/>
               <a:pPr/>
-              <a:t>6/7/26</a:t>
+              <a:t>6/10/26</a:t>
             </a:fld>
             <a:endParaRPr lang="en-US"/>
           </a:p>
@@ -27214,7 +27210,7 @@
           <a:p>
             <a:fld id="{6700A58B-DD98-43D0-B791-721480A02982}" type="datetime1">
               <a:rPr lang="en-US" smtClean="0"/>
-              <a:t>6/7/26</a:t>
+              <a:t>6/10/26</a:t>
             </a:fld>
             <a:endParaRPr lang="en-US"/>
           </a:p>
@@ -27580,7 +27576,7 @@
           <a:p>
             <a:fld id="{6700A58B-DD98-43D0-B791-721480A02982}" type="datetime1">
               <a:rPr lang="en-US" smtClean="0"/>
-              <a:t>6/7/26</a:t>
+              <a:t>6/10/26</a:t>
             </a:fld>
             <a:endParaRPr lang="en-US"/>
           </a:p>
@@ -28033,7 +28029,7 @@
           <a:p>
             <a:fld id="{6700A58B-DD98-43D0-B791-721480A02982}" type="datetime1">
               <a:rPr lang="en-US" smtClean="0"/>
-              <a:t>6/7/26</a:t>
+              <a:t>6/10/26</a:t>
             </a:fld>
             <a:endParaRPr lang="en-US"/>
           </a:p>
@@ -28887,7 +28883,7 @@
           <a:p>
             <a:fld id="{6700A58B-DD98-43D0-B791-721480A02982}" type="datetime1">
               <a:rPr lang="en-US" smtClean="0"/>
-              <a:t>6/7/26</a:t>
+              <a:t>6/10/26</a:t>
             </a:fld>
             <a:endParaRPr lang="en-US"/>
           </a:p>
@@ -29736,7 +29732,7 @@
           <a:p>
             <a:fld id="{6700A58B-DD98-43D0-B791-721480A02982}" type="datetime1">
               <a:rPr lang="en-US" smtClean="0"/>
-              <a:t>6/7/26</a:t>
+              <a:t>6/10/26</a:t>
             </a:fld>
             <a:endParaRPr lang="en-US"/>
           </a:p>
@@ -30097,7 +30093,7 @@
           <a:p>
             <a:fld id="{6700A58B-DD98-43D0-B791-721480A02982}" type="datetime1">
               <a:rPr lang="en-US" smtClean="0"/>
-              <a:t>6/7/26</a:t>
+              <a:t>6/10/26</a:t>
             </a:fld>
             <a:endParaRPr lang="en-US"/>
           </a:p>
@@ -30517,7 +30513,7 @@
           <a:p>
             <a:fld id="{6700A58B-DD98-43D0-B791-721480A02982}" type="datetime1">
               <a:rPr lang="en-US" smtClean="0"/>
-              <a:t>6/7/26</a:t>
+              <a:t>6/10/26</a:t>
             </a:fld>
             <a:endParaRPr lang="en-US"/>
           </a:p>
@@ -31241,7 +31237,7 @@
           <a:p>
             <a:fld id="{6700A58B-DD98-43D0-B791-721480A02982}" type="datetime1">
               <a:rPr lang="en-US" smtClean="0"/>
-              <a:t>6/7/26</a:t>
+              <a:t>6/10/26</a:t>
             </a:fld>
             <a:endParaRPr lang="en-US"/>
           </a:p>
@@ -32428,7 +32424,7 @@
           <a:p>
             <a:fld id="{6700A58B-DD98-43D0-B791-721480A02982}" type="datetime1">
               <a:rPr lang="en-US" smtClean="0"/>
-              <a:t>6/7/26</a:t>
+              <a:t>6/10/26</a:t>
             </a:fld>
             <a:endParaRPr lang="en-US"/>
           </a:p>
@@ -33351,7 +33347,7 @@
           <a:p>
             <a:fld id="{6700A58B-DD98-43D0-B791-721480A02982}" type="datetime1">
               <a:rPr lang="en-US" smtClean="0"/>
-              <a:t>6/7/26</a:t>
+              <a:t>6/10/26</a:t>
             </a:fld>
             <a:endParaRPr lang="en-US"/>
           </a:p>
@@ -33711,7 +33707,7 @@
             <a:fld id="{9B19E99B-5349-415A-8E56-8E989211A366}" type="datetime1">
               <a:rPr lang="en-US" smtClean="0"/>
               <a:pPr/>
-              <a:t>6/7/26</a:t>
+              <a:t>6/10/26</a:t>
             </a:fld>
             <a:endParaRPr lang="en-US"/>
           </a:p>
@@ -35355,7 +35351,7 @@
           <a:p>
             <a:fld id="{6700A58B-DD98-43D0-B791-721480A02982}" type="datetime1">
               <a:rPr lang="en-US" smtClean="0"/>
-              <a:t>6/7/26</a:t>
+              <a:t>6/10/26</a:t>
             </a:fld>
             <a:endParaRPr lang="en-US"/>
           </a:p>
@@ -36290,7 +36286,7 @@
           <a:p>
             <a:fld id="{6700A58B-DD98-43D0-B791-721480A02982}" type="datetime1">
               <a:rPr lang="en-US" smtClean="0"/>
-              <a:t>6/7/26</a:t>
+              <a:t>6/10/26</a:t>
             </a:fld>
             <a:endParaRPr lang="en-US"/>
           </a:p>
@@ -37741,7 +37737,7 @@
           <a:p>
             <a:fld id="{6700A58B-DD98-43D0-B791-721480A02982}" type="datetime1">
               <a:rPr lang="en-US" smtClean="0"/>
-              <a:t>6/7/26</a:t>
+              <a:t>6/10/26</a:t>
             </a:fld>
             <a:endParaRPr lang="en-US"/>
           </a:p>
@@ -38475,7 +38471,7 @@
           <a:p>
             <a:fld id="{6700A58B-DD98-43D0-B791-721480A02982}" type="datetime1">
               <a:rPr lang="en-US" smtClean="0"/>
-              <a:t>6/7/26</a:t>
+              <a:t>6/10/26</a:t>
             </a:fld>
             <a:endParaRPr lang="en-US"/>
           </a:p>
@@ -39523,7 +39519,7 @@
           <a:p>
             <a:fld id="{6700A58B-DD98-43D0-B791-721480A02982}" type="datetime1">
               <a:rPr lang="en-US" smtClean="0"/>
-              <a:t>6/7/26</a:t>
+              <a:t>6/10/26</a:t>
             </a:fld>
             <a:endParaRPr lang="en-US"/>
           </a:p>
@@ -40579,7 +40575,7 @@
           <a:p>
             <a:fld id="{6700A58B-DD98-43D0-B791-721480A02982}" type="datetime1">
               <a:rPr lang="en-US" smtClean="0"/>
-              <a:t>6/7/26</a:t>
+              <a:t>6/10/26</a:t>
             </a:fld>
             <a:endParaRPr lang="en-US"/>
           </a:p>
@@ -41479,7 +41475,7 @@
           <a:p>
             <a:fld id="{6700A58B-DD98-43D0-B791-721480A02982}" type="datetime1">
               <a:rPr lang="en-US" smtClean="0"/>
-              <a:t>6/7/26</a:t>
+              <a:t>6/10/26</a:t>
             </a:fld>
             <a:endParaRPr lang="en-US"/>
           </a:p>
@@ -42719,7 +42715,7 @@
           <a:p>
             <a:fld id="{6700A58B-DD98-43D0-B791-721480A02982}" type="datetime1">
               <a:rPr lang="en-US" smtClean="0"/>
-              <a:t>6/7/26</a:t>
+              <a:t>6/10/26</a:t>
             </a:fld>
             <a:endParaRPr lang="en-US"/>
           </a:p>
@@ -43816,7 +43812,7 @@
           <a:p>
             <a:fld id="{6700A58B-DD98-43D0-B791-721480A02982}" type="datetime1">
               <a:rPr lang="en-US" smtClean="0"/>
-              <a:t>6/7/26</a:t>
+              <a:t>6/10/26</a:t>
             </a:fld>
             <a:endParaRPr lang="en-US"/>
           </a:p>
@@ -44096,7 +44092,7 @@
           <a:p>
             <a:fld id="{6700A58B-DD98-43D0-B791-721480A02982}" type="datetime1">
               <a:rPr lang="en-US" smtClean="0"/>
-              <a:t>6/7/26</a:t>
+              <a:t>6/10/26</a:t>
             </a:fld>
             <a:endParaRPr lang="en-US"/>
           </a:p>
@@ -44567,7 +44563,7 @@
             <a:fld id="{6700A58B-DD98-43D0-B791-721480A02982}" type="datetime1">
               <a:rPr lang="en-US" smtClean="0"/>
               <a:pPr/>
-              <a:t>6/7/26</a:t>
+              <a:t>6/10/26</a:t>
             </a:fld>
             <a:endParaRPr lang="en-US"/>
           </a:p>
@@ -45024,7 +45020,7 @@
             <a:fld id="{6700A58B-DD98-43D0-B791-721480A02982}" type="datetime1">
               <a:rPr lang="en-US" smtClean="0"/>
               <a:pPr/>
-              <a:t>6/7/26</a:t>
+              <a:t>6/10/26</a:t>
             </a:fld>
             <a:endParaRPr lang="en-US"/>
           </a:p>
@@ -45559,7 +45555,7 @@
             <a:fld id="{6700A58B-DD98-43D0-B791-721480A02982}" type="datetime1">
               <a:rPr lang="en-US" smtClean="0"/>
               <a:pPr/>
-              <a:t>6/7/26</a:t>
+              <a:t>6/10/26</a:t>
             </a:fld>
             <a:endParaRPr lang="en-US"/>
           </a:p>

</xml_diff>